<commit_message>
!fixed question 1 in inclass quiz for WS1
</commit_message>
<xml_diff>
--- a/docs/misc/PM-WS1-1_2_oder_3.pptx
+++ b/docs/misc/PM-WS1-1_2_oder_3.pptx
@@ -317,7 +317,7 @@
           <a:p>
             <a:fld id="{3F4F00E9-D82E-4084-B41D-78A4468E89BE}" type="datetimeFigureOut">
               <a:rPr lang="de-CH" smtClean="0"/>
-              <a:t>03.03.2026</a:t>
+              <a:t>23.06.2026</a:t>
             </a:fld>
             <a:endParaRPr lang="de-CH"/>
           </a:p>
@@ -371,7 +371,7 @@
           <a:p>
             <a:fld id="{37C86B65-5DCA-4C76-8608-BE726E12FF55}" type="slidenum">
               <a:rPr lang="de-CH" smtClean="0"/>
-              <a:t>‹Nr.›</a:t>
+              <a:t>‹#›</a:t>
             </a:fld>
             <a:endParaRPr lang="de-CH"/>
           </a:p>
@@ -517,7 +517,7 @@
           <a:p>
             <a:fld id="{3F4F00E9-D82E-4084-B41D-78A4468E89BE}" type="datetimeFigureOut">
               <a:rPr lang="de-CH" smtClean="0"/>
-              <a:t>03.03.2026</a:t>
+              <a:t>23.06.2026</a:t>
             </a:fld>
             <a:endParaRPr lang="de-CH"/>
           </a:p>
@@ -571,7 +571,7 @@
           <a:p>
             <a:fld id="{37C86B65-5DCA-4C76-8608-BE726E12FF55}" type="slidenum">
               <a:rPr lang="de-CH" smtClean="0"/>
-              <a:t>‹Nr.›</a:t>
+              <a:t>‹#›</a:t>
             </a:fld>
             <a:endParaRPr lang="de-CH"/>
           </a:p>
@@ -727,7 +727,7 @@
           <a:p>
             <a:fld id="{3F4F00E9-D82E-4084-B41D-78A4468E89BE}" type="datetimeFigureOut">
               <a:rPr lang="de-CH" smtClean="0"/>
-              <a:t>03.03.2026</a:t>
+              <a:t>23.06.2026</a:t>
             </a:fld>
             <a:endParaRPr lang="de-CH"/>
           </a:p>
@@ -781,7 +781,7 @@
           <a:p>
             <a:fld id="{37C86B65-5DCA-4C76-8608-BE726E12FF55}" type="slidenum">
               <a:rPr lang="de-CH" smtClean="0"/>
-              <a:t>‹Nr.›</a:t>
+              <a:t>‹#›</a:t>
             </a:fld>
             <a:endParaRPr lang="de-CH"/>
           </a:p>
@@ -927,7 +927,7 @@
           <a:p>
             <a:fld id="{3F4F00E9-D82E-4084-B41D-78A4468E89BE}" type="datetimeFigureOut">
               <a:rPr lang="de-CH" smtClean="0"/>
-              <a:t>03.03.2026</a:t>
+              <a:t>23.06.2026</a:t>
             </a:fld>
             <a:endParaRPr lang="de-CH"/>
           </a:p>
@@ -981,7 +981,7 @@
           <a:p>
             <a:fld id="{37C86B65-5DCA-4C76-8608-BE726E12FF55}" type="slidenum">
               <a:rPr lang="de-CH" smtClean="0"/>
-              <a:t>‹Nr.›</a:t>
+              <a:t>‹#›</a:t>
             </a:fld>
             <a:endParaRPr lang="de-CH"/>
           </a:p>
@@ -1203,7 +1203,7 @@
           <a:p>
             <a:fld id="{3F4F00E9-D82E-4084-B41D-78A4468E89BE}" type="datetimeFigureOut">
               <a:rPr lang="de-CH" smtClean="0"/>
-              <a:t>03.03.2026</a:t>
+              <a:t>23.06.2026</a:t>
             </a:fld>
             <a:endParaRPr lang="de-CH"/>
           </a:p>
@@ -1257,7 +1257,7 @@
           <a:p>
             <a:fld id="{37C86B65-5DCA-4C76-8608-BE726E12FF55}" type="slidenum">
               <a:rPr lang="de-CH" smtClean="0"/>
-              <a:t>‹Nr.›</a:t>
+              <a:t>‹#›</a:t>
             </a:fld>
             <a:endParaRPr lang="de-CH"/>
           </a:p>
@@ -1471,7 +1471,7 @@
           <a:p>
             <a:fld id="{3F4F00E9-D82E-4084-B41D-78A4468E89BE}" type="datetimeFigureOut">
               <a:rPr lang="de-CH" smtClean="0"/>
-              <a:t>03.03.2026</a:t>
+              <a:t>23.06.2026</a:t>
             </a:fld>
             <a:endParaRPr lang="de-CH"/>
           </a:p>
@@ -1525,7 +1525,7 @@
           <a:p>
             <a:fld id="{37C86B65-5DCA-4C76-8608-BE726E12FF55}" type="slidenum">
               <a:rPr lang="de-CH" smtClean="0"/>
-              <a:t>‹Nr.›</a:t>
+              <a:t>‹#›</a:t>
             </a:fld>
             <a:endParaRPr lang="de-CH"/>
           </a:p>
@@ -1886,7 +1886,7 @@
           <a:p>
             <a:fld id="{3F4F00E9-D82E-4084-B41D-78A4468E89BE}" type="datetimeFigureOut">
               <a:rPr lang="de-CH" smtClean="0"/>
-              <a:t>03.03.2026</a:t>
+              <a:t>23.06.2026</a:t>
             </a:fld>
             <a:endParaRPr lang="de-CH"/>
           </a:p>
@@ -1940,7 +1940,7 @@
           <a:p>
             <a:fld id="{37C86B65-5DCA-4C76-8608-BE726E12FF55}" type="slidenum">
               <a:rPr lang="de-CH" smtClean="0"/>
-              <a:t>‹Nr.›</a:t>
+              <a:t>‹#›</a:t>
             </a:fld>
             <a:endParaRPr lang="de-CH"/>
           </a:p>
@@ -2028,7 +2028,7 @@
           <a:p>
             <a:fld id="{3F4F00E9-D82E-4084-B41D-78A4468E89BE}" type="datetimeFigureOut">
               <a:rPr lang="de-CH" smtClean="0"/>
-              <a:t>03.03.2026</a:t>
+              <a:t>23.06.2026</a:t>
             </a:fld>
             <a:endParaRPr lang="de-CH"/>
           </a:p>
@@ -2082,7 +2082,7 @@
           <a:p>
             <a:fld id="{37C86B65-5DCA-4C76-8608-BE726E12FF55}" type="slidenum">
               <a:rPr lang="de-CH" smtClean="0"/>
-              <a:t>‹Nr.›</a:t>
+              <a:t>‹#›</a:t>
             </a:fld>
             <a:endParaRPr lang="de-CH"/>
           </a:p>
@@ -2141,7 +2141,7 @@
           <a:p>
             <a:fld id="{3F4F00E9-D82E-4084-B41D-78A4468E89BE}" type="datetimeFigureOut">
               <a:rPr lang="de-CH" smtClean="0"/>
-              <a:t>03.03.2026</a:t>
+              <a:t>23.06.2026</a:t>
             </a:fld>
             <a:endParaRPr lang="de-CH"/>
           </a:p>
@@ -2195,7 +2195,7 @@
           <a:p>
             <a:fld id="{37C86B65-5DCA-4C76-8608-BE726E12FF55}" type="slidenum">
               <a:rPr lang="de-CH" smtClean="0"/>
-              <a:t>‹Nr.›</a:t>
+              <a:t>‹#›</a:t>
             </a:fld>
             <a:endParaRPr lang="de-CH"/>
           </a:p>
@@ -2454,7 +2454,7 @@
           <a:p>
             <a:fld id="{3F4F00E9-D82E-4084-B41D-78A4468E89BE}" type="datetimeFigureOut">
               <a:rPr lang="de-CH" smtClean="0"/>
-              <a:t>03.03.2026</a:t>
+              <a:t>23.06.2026</a:t>
             </a:fld>
             <a:endParaRPr lang="de-CH"/>
           </a:p>
@@ -2508,7 +2508,7 @@
           <a:p>
             <a:fld id="{37C86B65-5DCA-4C76-8608-BE726E12FF55}" type="slidenum">
               <a:rPr lang="de-CH" smtClean="0"/>
-              <a:t>‹Nr.›</a:t>
+              <a:t>‹#›</a:t>
             </a:fld>
             <a:endParaRPr lang="de-CH"/>
           </a:p>
@@ -2743,7 +2743,7 @@
           <a:p>
             <a:fld id="{3F4F00E9-D82E-4084-B41D-78A4468E89BE}" type="datetimeFigureOut">
               <a:rPr lang="de-CH" smtClean="0"/>
-              <a:t>03.03.2026</a:t>
+              <a:t>23.06.2026</a:t>
             </a:fld>
             <a:endParaRPr lang="de-CH"/>
           </a:p>
@@ -2797,7 +2797,7 @@
           <a:p>
             <a:fld id="{37C86B65-5DCA-4C76-8608-BE726E12FF55}" type="slidenum">
               <a:rPr lang="de-CH" smtClean="0"/>
-              <a:t>‹Nr.›</a:t>
+              <a:t>‹#›</a:t>
             </a:fld>
             <a:endParaRPr lang="de-CH"/>
           </a:p>
@@ -2986,7 +2986,7 @@
           <a:p>
             <a:fld id="{3F4F00E9-D82E-4084-B41D-78A4468E89BE}" type="datetimeFigureOut">
               <a:rPr lang="de-CH" smtClean="0"/>
-              <a:t>03.03.2026</a:t>
+              <a:t>23.06.2026</a:t>
             </a:fld>
             <a:endParaRPr lang="de-CH"/>
           </a:p>
@@ -3076,7 +3076,7 @@
           <a:p>
             <a:fld id="{37C86B65-5DCA-4C76-8608-BE726E12FF55}" type="slidenum">
               <a:rPr lang="de-CH" smtClean="0"/>
-              <a:t>‹Nr.›</a:t>
+              <a:t>‹#›</a:t>
             </a:fld>
             <a:endParaRPr lang="de-CH"/>
           </a:p>
@@ -3568,16 +3568,14 @@
             </a:pPr>
             <a:r>
               <a:rPr lang="en-US" dirty="0"/>
-              <a:t>What is the purpose of servo calibration (`</a:t>
-            </a:r>
-            <a:r>
-              <a:rPr lang="en-US" dirty="0" err="1"/>
-              <a:t>calibratePulseMinMax</a:t>
-            </a:r>
-            <a:r>
-              <a:rPr lang="en-US" dirty="0"/>
-              <a:t>`) before normal operation?</a:t>
-            </a:r>
+              <a:t>Why is a flow chart created before coding a robot task?</a:t>
+            </a:r>
+            <a:endParaRPr lang="de-CH" dirty="0"/>
+          </a:p>
+          <a:p>
+            <a:pPr marL="0" indent="0">
+              <a:buNone/>
+            </a:pPr>
             <a:br>
               <a:rPr lang="en-US" dirty="0"/>
             </a:br>

</xml_diff>